<commit_message>
Add new shape formats and update powerpoint
</commit_message>
<xml_diff>
--- a/powerpoint/Team Topologies Template for modelling - PowerPoint.pptx
+++ b/powerpoint/Team Topologies Template for modelling - PowerPoint.pptx
@@ -5,20 +5,21 @@
     <p:sldMasterId id="2147483659" r:id="rId1"/>
   </p:sldMasterIdLst>
   <p:notesMasterIdLst>
-    <p:notesMasterId r:id="rId3"/>
+    <p:notesMasterId r:id="rId4"/>
   </p:notesMasterIdLst>
   <p:sldIdLst>
     <p:sldId id="256" r:id="rId2"/>
+    <p:sldId id="257" r:id="rId3"/>
   </p:sldIdLst>
   <p:sldSz cx="9144000" cy="5143500" type="screen16x9"/>
   <p:notesSz cx="6858000" cy="9144000"/>
   <p:embeddedFontLst>
     <p:embeddedFont>
       <p:font typeface="Open Sans" panose="020B0606030504020204" pitchFamily="34" charset="0"/>
-      <p:regular r:id="rId4"/>
-      <p:bold r:id="rId5"/>
-      <p:italic r:id="rId6"/>
-      <p:boldItalic r:id="rId7"/>
+      <p:regular r:id="rId5"/>
+      <p:bold r:id="rId6"/>
+      <p:italic r:id="rId7"/>
+      <p:boldItalic r:id="rId8"/>
     </p:embeddedFont>
   </p:embeddedFontLst>
   <p:defaultTextStyle>
@@ -807,6 +808,133 @@
         </p:txBody>
       </p:sp>
     </p:spTree>
+  </p:cSld>
+  <p:clrMapOvr>
+    <a:masterClrMapping/>
+  </p:clrMapOvr>
+</p:notes>
+</file>
+
+<file path=ppt/notesSlides/notesSlide2.xml><?xml version="1.0" encoding="utf-8"?>
+<p:notes xmlns:a="http://schemas.openxmlformats.org/drawingml/2006/main" xmlns:r="http://schemas.openxmlformats.org/officeDocument/2006/relationships" xmlns:p="http://schemas.openxmlformats.org/presentationml/2006/main" showMasterSp="0" showMasterPhAnim="0">
+  <p:cSld>
+    <p:spTree>
+      <p:nvGrpSpPr>
+        <p:cNvPr id="1" name="Shape 50">
+          <a:extLst>
+            <a:ext uri="{FF2B5EF4-FFF2-40B4-BE49-F238E27FC236}">
+              <a16:creationId xmlns:a16="http://schemas.microsoft.com/office/drawing/2014/main" id="{400EC917-14A3-E32F-A74B-C8F50F51F706}"/>
+            </a:ext>
+          </a:extLst>
+        </p:cNvPr>
+        <p:cNvGrpSpPr/>
+        <p:nvPr/>
+      </p:nvGrpSpPr>
+      <p:grpSpPr>
+        <a:xfrm>
+          <a:off x="0" y="0"/>
+          <a:ext cx="0" cy="0"/>
+          <a:chOff x="0" y="0"/>
+          <a:chExt cx="0" cy="0"/>
+        </a:xfrm>
+      </p:grpSpPr>
+      <p:sp>
+        <p:nvSpPr>
+          <p:cNvPr id="51" name="Google Shape;51;p:notes">
+            <a:extLst>
+              <a:ext uri="{FF2B5EF4-FFF2-40B4-BE49-F238E27FC236}">
+                <a16:creationId xmlns:a16="http://schemas.microsoft.com/office/drawing/2014/main" id="{99BF2C35-5525-18CA-16BE-9DBC403CC657}"/>
+              </a:ext>
+            </a:extLst>
+          </p:cNvPr>
+          <p:cNvSpPr>
+            <a:spLocks noGrp="1" noRot="1" noChangeAspect="1"/>
+          </p:cNvSpPr>
+          <p:nvPr>
+            <p:ph type="sldImg" idx="2"/>
+          </p:nvPr>
+        </p:nvSpPr>
+        <p:spPr>
+          <a:xfrm>
+            <a:off x="381000" y="685800"/>
+            <a:ext cx="6096000" cy="3429000"/>
+          </a:xfrm>
+          <a:custGeom>
+            <a:avLst/>
+            <a:gdLst/>
+            <a:ahLst/>
+            <a:cxnLst/>
+            <a:rect l="l" t="t" r="r" b="b"/>
+            <a:pathLst>
+              <a:path w="120000" h="120000" extrusionOk="0">
+                <a:moveTo>
+                  <a:pt x="0" y="0"/>
+                </a:moveTo>
+                <a:lnTo>
+                  <a:pt x="120000" y="0"/>
+                </a:lnTo>
+                <a:lnTo>
+                  <a:pt x="120000" y="120000"/>
+                </a:lnTo>
+                <a:lnTo>
+                  <a:pt x="0" y="120000"/>
+                </a:lnTo>
+                <a:close/>
+              </a:path>
+            </a:pathLst>
+          </a:custGeom>
+        </p:spPr>
+      </p:sp>
+      <p:sp>
+        <p:nvSpPr>
+          <p:cNvPr id="52" name="Google Shape;52;p:notes">
+            <a:extLst>
+              <a:ext uri="{FF2B5EF4-FFF2-40B4-BE49-F238E27FC236}">
+                <a16:creationId xmlns:a16="http://schemas.microsoft.com/office/drawing/2014/main" id="{F7FEAAE3-818A-2E9F-3DC9-59CC208FE6C0}"/>
+              </a:ext>
+            </a:extLst>
+          </p:cNvPr>
+          <p:cNvSpPr txBox="1">
+            <a:spLocks noGrp="1"/>
+          </p:cNvSpPr>
+          <p:nvPr>
+            <p:ph type="body" idx="1"/>
+          </p:nvPr>
+        </p:nvSpPr>
+        <p:spPr>
+          <a:xfrm>
+            <a:off x="685800" y="4343400"/>
+            <a:ext cx="5486400" cy="4114800"/>
+          </a:xfrm>
+          <a:prstGeom prst="rect">
+            <a:avLst/>
+          </a:prstGeom>
+        </p:spPr>
+        <p:txBody>
+          <a:bodyPr spcFirstLastPara="1" wrap="square" lIns="91425" tIns="91425" rIns="91425" bIns="91425" anchor="t" anchorCtr="0">
+            <a:noAutofit/>
+          </a:bodyPr>
+          <a:lstStyle/>
+          <a:p>
+            <a:pPr marL="0" lvl="0" indent="0" algn="l" rtl="0">
+              <a:spcBef>
+                <a:spcPts val="0"/>
+              </a:spcBef>
+              <a:spcAft>
+                <a:spcPts val="0"/>
+              </a:spcAft>
+              <a:buNone/>
+            </a:pPr>
+            <a:endParaRPr/>
+          </a:p>
+        </p:txBody>
+      </p:sp>
+    </p:spTree>
+    <p:extLst>
+      <p:ext uri="{BB962C8B-B14F-4D97-AF65-F5344CB8AC3E}">
+        <p14:creationId xmlns:p14="http://schemas.microsoft.com/office/powerpoint/2010/main" val="2069097974"/>
+      </p:ext>
+    </p:extLst>
   </p:cSld>
   <p:clrMapOvr>
     <a:masterClrMapping/>
@@ -5650,8 +5778,8 @@
         </p:nvSpPr>
         <p:spPr>
           <a:xfrm>
-            <a:off x="399833" y="3469648"/>
-            <a:ext cx="3132813" cy="347968"/>
+            <a:off x="3959226" y="1805582"/>
+            <a:ext cx="1892309" cy="347968"/>
           </a:xfrm>
           <a:prstGeom prst="roundRect">
             <a:avLst>
@@ -5687,13 +5815,13 @@
               <a:buNone/>
             </a:pPr>
             <a:r>
-              <a:rPr lang="en-GB" sz="800" dirty="0">
+              <a:rPr lang="en-GB" sz="800">
                 <a:latin typeface="Open Sans"/>
                 <a:ea typeface="Open Sans"/>
                 <a:cs typeface="Open Sans"/>
                 <a:sym typeface="Open Sans"/>
               </a:rPr>
-              <a:t>Platform team</a:t>
+              <a:t>Platform Grouping</a:t>
             </a:r>
             <a:endParaRPr sz="800" dirty="0">
               <a:latin typeface="Open Sans"/>
@@ -5950,7 +6078,7 @@
         </p:nvSpPr>
         <p:spPr>
           <a:xfrm>
-            <a:off x="4160929" y="1207405"/>
+            <a:off x="6699342" y="1207711"/>
             <a:ext cx="1403825" cy="515013"/>
           </a:xfrm>
           <a:prstGeom prst="flowChartInputOutput">
@@ -6048,7 +6176,7 @@
                 <a:cs typeface="Open Sans"/>
                 <a:sym typeface="Open Sans"/>
               </a:rPr>
-              <a:t>Fundamental Team Types</a:t>
+              <a:t>Fundamental Topologies</a:t>
             </a:r>
             <a:endParaRPr sz="1000" dirty="0">
               <a:latin typeface="Open Sans"/>
@@ -6103,7 +6231,7 @@
                 <a:cs typeface="Open Sans"/>
                 <a:sym typeface="Open Sans"/>
               </a:rPr>
-              <a:t>Team Interaction Modes</a:t>
+              <a:t>Fundamental Groupings</a:t>
             </a:r>
             <a:endParaRPr sz="1000" dirty="0">
               <a:latin typeface="Open Sans"/>
@@ -6122,7 +6250,7 @@
         </p:nvSpPr>
         <p:spPr>
           <a:xfrm>
-            <a:off x="4400765" y="1849400"/>
+            <a:off x="6939178" y="1849706"/>
             <a:ext cx="915000" cy="804300"/>
           </a:xfrm>
           <a:prstGeom prst="triangle">
@@ -6186,7 +6314,7 @@
         </p:nvSpPr>
         <p:spPr>
           <a:xfrm>
-            <a:off x="4359965" y="2842282"/>
+            <a:off x="6898378" y="2842588"/>
             <a:ext cx="996600" cy="1008000"/>
           </a:xfrm>
           <a:prstGeom prst="ellipse">
@@ -6346,104 +6474,12 @@
             </a:pPr>
             <a:r>
               <a:rPr lang="en-GB" sz="800" dirty="0"/>
-              <a:t>Flow of change</a:t>
+              <a:t>Flow of value: {scenario}</a:t>
             </a:r>
             <a:endParaRPr sz="800" dirty="0"/>
           </a:p>
         </p:txBody>
       </p:sp>
-      <p:grpSp>
-        <p:nvGrpSpPr>
-          <p:cNvPr id="5" name="Group 4">
-            <a:extLst>
-              <a:ext uri="{FF2B5EF4-FFF2-40B4-BE49-F238E27FC236}">
-                <a16:creationId xmlns:a16="http://schemas.microsoft.com/office/drawing/2014/main" id="{B0B7A22E-1CD1-684B-B2B1-38F1A5B57D98}"/>
-              </a:ext>
-            </a:extLst>
-          </p:cNvPr>
-          <p:cNvGrpSpPr/>
-          <p:nvPr/>
-        </p:nvGrpSpPr>
-        <p:grpSpPr>
-          <a:xfrm>
-            <a:off x="6049008" y="1230413"/>
-            <a:ext cx="2669296" cy="398915"/>
-            <a:chOff x="1011391" y="3758799"/>
-            <a:chExt cx="3132813" cy="398915"/>
-          </a:xfrm>
-        </p:grpSpPr>
-        <p:pic>
-          <p:nvPicPr>
-            <p:cNvPr id="3" name="Graphic 2">
-              <a:extLst>
-                <a:ext uri="{FF2B5EF4-FFF2-40B4-BE49-F238E27FC236}">
-                  <a16:creationId xmlns:a16="http://schemas.microsoft.com/office/drawing/2014/main" id="{A98A8545-9DE1-9345-A5E4-0302CA02559A}"/>
-                </a:ext>
-              </a:extLst>
-            </p:cNvPr>
-            <p:cNvPicPr>
-              <a:picLocks noChangeAspect="1"/>
-            </p:cNvPicPr>
-            <p:nvPr/>
-          </p:nvPicPr>
-          <p:blipFill>
-            <a:blip r:embed="rId4">
-              <a:extLst>
-                <a:ext uri="{96DAC541-7B7A-43D3-8B79-37D633B846F1}">
-                  <asvg:svgBlip xmlns:asvg="http://schemas.microsoft.com/office/drawing/2016/SVG/main" r:embed="rId5"/>
-                </a:ext>
-              </a:extLst>
-            </a:blip>
-            <a:stretch>
-              <a:fillRect/>
-            </a:stretch>
-          </p:blipFill>
-          <p:spPr>
-            <a:xfrm>
-              <a:off x="1011391" y="3758799"/>
-              <a:ext cx="3132813" cy="398915"/>
-            </a:xfrm>
-            <a:prstGeom prst="rect">
-              <a:avLst/>
-            </a:prstGeom>
-          </p:spPr>
-        </p:pic>
-        <p:sp>
-          <p:nvSpPr>
-            <p:cNvPr id="4" name="TextBox 3">
-              <a:extLst>
-                <a:ext uri="{FF2B5EF4-FFF2-40B4-BE49-F238E27FC236}">
-                  <a16:creationId xmlns:a16="http://schemas.microsoft.com/office/drawing/2014/main" id="{72F828F6-042B-F940-B643-961706018CC6}"/>
-                </a:ext>
-              </a:extLst>
-            </p:cNvPr>
-            <p:cNvSpPr txBox="1"/>
-            <p:nvPr/>
-          </p:nvSpPr>
-          <p:spPr>
-            <a:xfrm>
-              <a:off x="1870217" y="3850534"/>
-              <a:ext cx="1415160" cy="215444"/>
-            </a:xfrm>
-            <a:prstGeom prst="rect">
-              <a:avLst/>
-            </a:prstGeom>
-            <a:noFill/>
-          </p:spPr>
-          <p:txBody>
-            <a:bodyPr wrap="none" rtlCol="0">
-              <a:spAutoFit/>
-            </a:bodyPr>
-            <a:lstStyle/>
-            <a:p>
-              <a:r>
-                <a:rPr lang="en-US" sz="800" dirty="0"/>
-                <a:t>Undefined Team Type</a:t>
-              </a:r>
-            </a:p>
-          </p:txBody>
-        </p:sp>
-      </p:grpSp>
       <p:sp>
         <p:nvSpPr>
           <p:cNvPr id="17" name="Google Shape;60;p13">
@@ -6494,6 +6530,286 @@
                 <a:cs typeface="Open Sans"/>
                 <a:sym typeface="Open Sans"/>
               </a:rPr>
+              <a:t>Team Interaction Modes</a:t>
+            </a:r>
+            <a:endParaRPr sz="1000" dirty="0">
+              <a:latin typeface="Open Sans"/>
+              <a:ea typeface="Open Sans"/>
+              <a:cs typeface="Open Sans"/>
+              <a:sym typeface="Open Sans"/>
+            </a:endParaRPr>
+          </a:p>
+        </p:txBody>
+      </p:sp>
+      <p:sp>
+        <p:nvSpPr>
+          <p:cNvPr id="6" name="Google Shape;55;p13">
+            <a:extLst>
+              <a:ext uri="{FF2B5EF4-FFF2-40B4-BE49-F238E27FC236}">
+                <a16:creationId xmlns:a16="http://schemas.microsoft.com/office/drawing/2014/main" id="{3BF36998-4566-92A7-4C43-44D97F9924C0}"/>
+              </a:ext>
+            </a:extLst>
+          </p:cNvPr>
+          <p:cNvSpPr/>
+          <p:nvPr/>
+        </p:nvSpPr>
+        <p:spPr>
+          <a:xfrm>
+            <a:off x="3959225" y="1207711"/>
+            <a:ext cx="1892309" cy="347968"/>
+          </a:xfrm>
+          <a:prstGeom prst="roundRect">
+            <a:avLst>
+              <a:gd name="adj" fmla="val 0"/>
+            </a:avLst>
+          </a:prstGeom>
+          <a:solidFill>
+            <a:srgbClr val="FFEDB8"/>
+          </a:solidFill>
+          <a:ln w="25400" cap="flat" cmpd="sng">
+            <a:solidFill>
+              <a:srgbClr val="FFD966"/>
+            </a:solidFill>
+            <a:prstDash val="sysDot"/>
+            <a:round/>
+            <a:headEnd type="none" w="sm" len="sm"/>
+            <a:tailEnd type="none" w="sm" len="sm"/>
+          </a:ln>
+        </p:spPr>
+        <p:txBody>
+          <a:bodyPr spcFirstLastPara="1" wrap="square" lIns="91425" tIns="91425" rIns="91425" bIns="91425" anchor="ctr" anchorCtr="0">
+            <a:noAutofit/>
+          </a:bodyPr>
+          <a:lstStyle/>
+          <a:p>
+            <a:pPr marL="0" lvl="0" indent="0" algn="ctr" rtl="0">
+              <a:spcBef>
+                <a:spcPts val="0"/>
+              </a:spcBef>
+              <a:spcAft>
+                <a:spcPts val="0"/>
+              </a:spcAft>
+              <a:buNone/>
+            </a:pPr>
+            <a:r>
+              <a:rPr lang="en-GB" sz="800" dirty="0">
+                <a:latin typeface="Open Sans"/>
+                <a:ea typeface="Open Sans"/>
+                <a:cs typeface="Open Sans"/>
+                <a:sym typeface="Open Sans"/>
+              </a:rPr>
+              <a:t>Value Stream Grouping</a:t>
+            </a:r>
+            <a:endParaRPr sz="800" dirty="0">
+              <a:latin typeface="Open Sans"/>
+              <a:ea typeface="Open Sans"/>
+              <a:cs typeface="Open Sans"/>
+              <a:sym typeface="Open Sans"/>
+            </a:endParaRPr>
+          </a:p>
+        </p:txBody>
+      </p:sp>
+    </p:spTree>
+  </p:cSld>
+  <p:clrMapOvr>
+    <a:masterClrMapping/>
+  </p:clrMapOvr>
+</p:sld>
+</file>
+
+<file path=ppt/slides/slide2.xml><?xml version="1.0" encoding="utf-8"?>
+<p:sld xmlns:a="http://schemas.openxmlformats.org/drawingml/2006/main" xmlns:r="http://schemas.openxmlformats.org/officeDocument/2006/relationships" xmlns:p="http://schemas.openxmlformats.org/presentationml/2006/main">
+  <p:cSld>
+    <p:spTree>
+      <p:nvGrpSpPr>
+        <p:cNvPr id="1" name="Shape 53">
+          <a:extLst>
+            <a:ext uri="{FF2B5EF4-FFF2-40B4-BE49-F238E27FC236}">
+              <a16:creationId xmlns:a16="http://schemas.microsoft.com/office/drawing/2014/main" id="{CFD2F276-AF2B-8373-C6BE-C5F7C0D36658}"/>
+            </a:ext>
+          </a:extLst>
+        </p:cNvPr>
+        <p:cNvGrpSpPr/>
+        <p:nvPr/>
+      </p:nvGrpSpPr>
+      <p:grpSpPr>
+        <a:xfrm>
+          <a:off x="0" y="0"/>
+          <a:ext cx="0" cy="0"/>
+          <a:chOff x="0" y="0"/>
+          <a:chExt cx="0" cy="0"/>
+        </a:xfrm>
+      </p:grpSpPr>
+      <p:sp>
+        <p:nvSpPr>
+          <p:cNvPr id="58" name="Google Shape;58;p13">
+            <a:extLst>
+              <a:ext uri="{FF2B5EF4-FFF2-40B4-BE49-F238E27FC236}">
+                <a16:creationId xmlns:a16="http://schemas.microsoft.com/office/drawing/2014/main" id="{7F3ED5E9-9D43-91C7-F635-89652820A2C7}"/>
+              </a:ext>
+            </a:extLst>
+          </p:cNvPr>
+          <p:cNvSpPr txBox="1"/>
+          <p:nvPr/>
+        </p:nvSpPr>
+        <p:spPr>
+          <a:xfrm>
+            <a:off x="2575156" y="88961"/>
+            <a:ext cx="5927049" cy="943500"/>
+          </a:xfrm>
+          <a:prstGeom prst="rect">
+            <a:avLst/>
+          </a:prstGeom>
+          <a:noFill/>
+          <a:ln>
+            <a:noFill/>
+          </a:ln>
+        </p:spPr>
+        <p:txBody>
+          <a:bodyPr spcFirstLastPara="1" wrap="square" lIns="91425" tIns="91425" rIns="91425" bIns="91425" anchor="t" anchorCtr="0">
+            <a:noAutofit/>
+          </a:bodyPr>
+          <a:lstStyle/>
+          <a:p>
+            <a:pPr marL="0" lvl="0" indent="0" algn="l" rtl="0">
+              <a:lnSpc>
+                <a:spcPct val="115000"/>
+              </a:lnSpc>
+              <a:spcBef>
+                <a:spcPts val="0"/>
+              </a:spcBef>
+              <a:spcAft>
+                <a:spcPts val="0"/>
+              </a:spcAft>
+              <a:buNone/>
+            </a:pPr>
+            <a:r>
+              <a:rPr lang="en-GB" sz="900" dirty="0">
+                <a:solidFill>
+                  <a:srgbClr val="434343"/>
+                </a:solidFill>
+                <a:latin typeface="Open Sans"/>
+                <a:ea typeface="Open Sans"/>
+                <a:cs typeface="Open Sans"/>
+                <a:sym typeface="Open Sans"/>
+              </a:rPr>
+              <a:t>These shapes can be used as copy/paste templates for modelling organization design and team interactions based on the ideas in Team Topologies. See</a:t>
+            </a:r>
+            <a:r>
+              <a:rPr lang="en-GB" sz="900" dirty="0">
+                <a:solidFill>
+                  <a:srgbClr val="434343"/>
+                </a:solidFill>
+                <a:uFill>
+                  <a:noFill/>
+                </a:uFill>
+                <a:latin typeface="Open Sans"/>
+                <a:ea typeface="Open Sans"/>
+                <a:cs typeface="Open Sans"/>
+                <a:sym typeface="Open Sans"/>
+                <a:hlinkClick r:id="rId3">
+                  <a:extLst>
+                    <a:ext uri="{A12FA001-AC4F-418D-AE19-62706E023703}">
+                      <ahyp:hlinkClr xmlns:ahyp="http://schemas.microsoft.com/office/drawing/2018/hyperlinkcolor" val="tx"/>
+                    </a:ext>
+                  </a:extLst>
+                </a:hlinkClick>
+              </a:rPr>
+              <a:t> </a:t>
+            </a:r>
+            <a:r>
+              <a:rPr lang="en-GB" sz="900" u="sng" dirty="0">
+                <a:solidFill>
+                  <a:srgbClr val="434343"/>
+                </a:solidFill>
+                <a:latin typeface="Open Sans"/>
+                <a:ea typeface="Open Sans"/>
+                <a:cs typeface="Open Sans"/>
+                <a:sym typeface="Open Sans"/>
+                <a:hlinkClick r:id="rId3">
+                  <a:extLst>
+                    <a:ext uri="{A12FA001-AC4F-418D-AE19-62706E023703}">
+                      <ahyp:hlinkClr xmlns:ahyp="http://schemas.microsoft.com/office/drawing/2018/hyperlinkcolor" val="tx"/>
+                    </a:ext>
+                  </a:extLst>
+                </a:hlinkClick>
+              </a:rPr>
+              <a:t>teamtopologies.com</a:t>
+            </a:r>
+            <a:r>
+              <a:rPr lang="en-GB" sz="900" dirty="0">
+                <a:solidFill>
+                  <a:srgbClr val="434343"/>
+                </a:solidFill>
+                <a:latin typeface="Open Sans"/>
+                <a:ea typeface="Open Sans"/>
+                <a:cs typeface="Open Sans"/>
+                <a:sym typeface="Open Sans"/>
+              </a:rPr>
+              <a:t> for more details. We have tried to make the shapes match as closely as possible to those in the book, but some shapes are slightly different.</a:t>
+            </a:r>
+            <a:endParaRPr sz="900" dirty="0">
+              <a:solidFill>
+                <a:srgbClr val="434343"/>
+              </a:solidFill>
+              <a:latin typeface="Open Sans"/>
+              <a:ea typeface="Open Sans"/>
+              <a:cs typeface="Open Sans"/>
+              <a:sym typeface="Open Sans"/>
+            </a:endParaRPr>
+          </a:p>
+        </p:txBody>
+      </p:sp>
+      <p:sp>
+        <p:nvSpPr>
+          <p:cNvPr id="60" name="Google Shape;60;p13">
+            <a:extLst>
+              <a:ext uri="{FF2B5EF4-FFF2-40B4-BE49-F238E27FC236}">
+                <a16:creationId xmlns:a16="http://schemas.microsoft.com/office/drawing/2014/main" id="{BA4D9BF0-71C7-D5D3-8E22-F069CE2FB683}"/>
+              </a:ext>
+            </a:extLst>
+          </p:cNvPr>
+          <p:cNvSpPr txBox="1"/>
+          <p:nvPr/>
+        </p:nvSpPr>
+        <p:spPr>
+          <a:xfrm>
+            <a:off x="338055" y="891706"/>
+            <a:ext cx="2237100" cy="276600"/>
+          </a:xfrm>
+          <a:prstGeom prst="rect">
+            <a:avLst/>
+          </a:prstGeom>
+          <a:noFill/>
+          <a:ln>
+            <a:noFill/>
+          </a:ln>
+        </p:spPr>
+        <p:txBody>
+          <a:bodyPr spcFirstLastPara="1" wrap="square" lIns="91425" tIns="91425" rIns="91425" bIns="91425" anchor="t" anchorCtr="0">
+            <a:noAutofit/>
+          </a:bodyPr>
+          <a:lstStyle/>
+          <a:p>
+            <a:pPr marL="0" lvl="0" indent="0" algn="ctr" rtl="0">
+              <a:spcBef>
+                <a:spcPts val="0"/>
+              </a:spcBef>
+              <a:spcAft>
+                <a:spcPts val="0"/>
+              </a:spcAft>
+              <a:buNone/>
+            </a:pPr>
+            <a:r>
+              <a:rPr lang="en-GB" sz="1000" b="1" u="sng" dirty="0">
+                <a:solidFill>
+                  <a:srgbClr val="1A1A1A"/>
+                </a:solidFill>
+                <a:latin typeface="Open Sans"/>
+                <a:ea typeface="Open Sans"/>
+                <a:cs typeface="Open Sans"/>
+                <a:sym typeface="Open Sans"/>
+              </a:rPr>
               <a:t>Supplementary Team Types</a:t>
             </a:r>
             <a:endParaRPr sz="1000" dirty="0">
@@ -6505,7 +6821,475 @@
           </a:p>
         </p:txBody>
       </p:sp>
+      <p:sp>
+        <p:nvSpPr>
+          <p:cNvPr id="64" name="Google Shape;64;p13">
+            <a:extLst>
+              <a:ext uri="{FF2B5EF4-FFF2-40B4-BE49-F238E27FC236}">
+                <a16:creationId xmlns:a16="http://schemas.microsoft.com/office/drawing/2014/main" id="{B2014498-4074-55EC-06CA-B44A47D1703B}"/>
+              </a:ext>
+            </a:extLst>
+          </p:cNvPr>
+          <p:cNvSpPr txBox="1"/>
+          <p:nvPr/>
+        </p:nvSpPr>
+        <p:spPr>
+          <a:xfrm>
+            <a:off x="543257" y="97773"/>
+            <a:ext cx="2031900" cy="553968"/>
+          </a:xfrm>
+          <a:prstGeom prst="rect">
+            <a:avLst/>
+          </a:prstGeom>
+          <a:noFill/>
+          <a:ln>
+            <a:noFill/>
+          </a:ln>
+        </p:spPr>
+        <p:txBody>
+          <a:bodyPr spcFirstLastPara="1" wrap="square" lIns="91425" tIns="91425" rIns="91425" bIns="91425" anchor="t" anchorCtr="0">
+            <a:spAutoFit/>
+          </a:bodyPr>
+          <a:lstStyle/>
+          <a:p>
+            <a:pPr marL="0" lvl="0" indent="0" algn="l" rtl="0">
+              <a:spcBef>
+                <a:spcPts val="0"/>
+              </a:spcBef>
+              <a:spcAft>
+                <a:spcPts val="0"/>
+              </a:spcAft>
+              <a:buNone/>
+            </a:pPr>
+            <a:r>
+              <a:rPr lang="en-GB" sz="1200" b="1" dirty="0">
+                <a:latin typeface="Open Sans"/>
+                <a:ea typeface="Open Sans"/>
+                <a:cs typeface="Open Sans"/>
+                <a:sym typeface="Open Sans"/>
+              </a:rPr>
+              <a:t>Team Topologies </a:t>
+            </a:r>
+            <a:r>
+              <a:rPr lang="en-GB" sz="1200" dirty="0">
+                <a:latin typeface="Open Sans"/>
+                <a:ea typeface="Open Sans"/>
+                <a:cs typeface="Open Sans"/>
+                <a:sym typeface="Open Sans"/>
+              </a:rPr>
+              <a:t>team shapes template</a:t>
+            </a:r>
+            <a:endParaRPr sz="1200" dirty="0">
+              <a:latin typeface="Open Sans"/>
+              <a:ea typeface="Open Sans"/>
+              <a:cs typeface="Open Sans"/>
+              <a:sym typeface="Open Sans"/>
+            </a:endParaRPr>
+          </a:p>
+        </p:txBody>
+      </p:sp>
+      <p:sp>
+        <p:nvSpPr>
+          <p:cNvPr id="7" name="Google Shape;60;p13">
+            <a:extLst>
+              <a:ext uri="{FF2B5EF4-FFF2-40B4-BE49-F238E27FC236}">
+                <a16:creationId xmlns:a16="http://schemas.microsoft.com/office/drawing/2014/main" id="{EB05C978-4BFD-32AD-EECD-E81136B2794E}"/>
+              </a:ext>
+            </a:extLst>
+          </p:cNvPr>
+          <p:cNvSpPr txBox="1"/>
+          <p:nvPr/>
+        </p:nvSpPr>
+        <p:spPr>
+          <a:xfrm>
+            <a:off x="435036" y="2921397"/>
+            <a:ext cx="2425927" cy="276600"/>
+          </a:xfrm>
+          <a:prstGeom prst="rect">
+            <a:avLst/>
+          </a:prstGeom>
+          <a:noFill/>
+          <a:ln>
+            <a:noFill/>
+          </a:ln>
+        </p:spPr>
+        <p:txBody>
+          <a:bodyPr spcFirstLastPara="1" wrap="square" lIns="91425" tIns="91425" rIns="91425" bIns="91425" anchor="t" anchorCtr="0">
+            <a:noAutofit/>
+          </a:bodyPr>
+          <a:lstStyle/>
+          <a:p>
+            <a:pPr marL="0" lvl="0" indent="0" algn="ctr" rtl="0">
+              <a:spcBef>
+                <a:spcPts val="0"/>
+              </a:spcBef>
+              <a:spcAft>
+                <a:spcPts val="0"/>
+              </a:spcAft>
+              <a:buNone/>
+            </a:pPr>
+            <a:r>
+              <a:rPr lang="en-GB" sz="1000" b="1" u="sng" dirty="0">
+                <a:solidFill>
+                  <a:srgbClr val="1A1A1A"/>
+                </a:solidFill>
+                <a:latin typeface="Open Sans"/>
+                <a:ea typeface="Open Sans"/>
+                <a:cs typeface="Open Sans"/>
+                <a:sym typeface="Open Sans"/>
+              </a:rPr>
+              <a:t>Supplementary Interaction Modes</a:t>
+            </a:r>
+            <a:endParaRPr sz="1000" dirty="0">
+              <a:latin typeface="Open Sans"/>
+              <a:ea typeface="Open Sans"/>
+              <a:cs typeface="Open Sans"/>
+              <a:sym typeface="Open Sans"/>
+            </a:endParaRPr>
+          </a:p>
+        </p:txBody>
+      </p:sp>
+      <p:sp>
+        <p:nvSpPr>
+          <p:cNvPr id="11" name="Rectangle: Rounded Corners 10">
+            <a:extLst>
+              <a:ext uri="{FF2B5EF4-FFF2-40B4-BE49-F238E27FC236}">
+                <a16:creationId xmlns:a16="http://schemas.microsoft.com/office/drawing/2014/main" id="{33D829DA-15C9-3A60-BF37-02741D814508}"/>
+              </a:ext>
+            </a:extLst>
+          </p:cNvPr>
+          <p:cNvSpPr/>
+          <p:nvPr/>
+        </p:nvSpPr>
+        <p:spPr>
+          <a:xfrm>
+            <a:off x="543257" y="1578014"/>
+            <a:ext cx="2001981" cy="398915"/>
+          </a:xfrm>
+          <a:prstGeom prst="roundRect">
+            <a:avLst/>
+          </a:prstGeom>
+          <a:solidFill>
+            <a:srgbClr val="EBEBEF"/>
+          </a:solidFill>
+          <a:ln>
+            <a:solidFill>
+              <a:srgbClr val="9B99AF"/>
+            </a:solidFill>
+            <a:prstDash val="dash"/>
+          </a:ln>
+        </p:spPr>
+        <p:style>
+          <a:lnRef idx="2">
+            <a:schemeClr val="accent1">
+              <a:shade val="15000"/>
+            </a:schemeClr>
+          </a:lnRef>
+          <a:fillRef idx="1">
+            <a:schemeClr val="accent1"/>
+          </a:fillRef>
+          <a:effectRef idx="0">
+            <a:schemeClr val="accent1"/>
+          </a:effectRef>
+          <a:fontRef idx="minor">
+            <a:schemeClr val="lt1"/>
+          </a:fontRef>
+        </p:style>
+        <p:txBody>
+          <a:bodyPr rtlCol="0" anchor="ctr"/>
+          <a:lstStyle/>
+          <a:p>
+            <a:pPr algn="ctr"/>
+            <a:r>
+              <a:rPr lang="en-US" sz="800" dirty="0">
+                <a:solidFill>
+                  <a:schemeClr val="tx1"/>
+                </a:solidFill>
+              </a:rPr>
+              <a:t>Undefined Team Type</a:t>
+            </a:r>
+          </a:p>
+        </p:txBody>
+      </p:sp>
+      <p:sp>
+        <p:nvSpPr>
+          <p:cNvPr id="13" name="Rectangle 12">
+            <a:extLst>
+              <a:ext uri="{FF2B5EF4-FFF2-40B4-BE49-F238E27FC236}">
+                <a16:creationId xmlns:a16="http://schemas.microsoft.com/office/drawing/2014/main" id="{D5770BBB-75BD-1A7E-5609-7B4EDAF08DDA}"/>
+              </a:ext>
+            </a:extLst>
+          </p:cNvPr>
+          <p:cNvSpPr/>
+          <p:nvPr/>
+        </p:nvSpPr>
+        <p:spPr>
+          <a:xfrm>
+            <a:off x="1066454" y="3466950"/>
+            <a:ext cx="1163089" cy="1073300"/>
+          </a:xfrm>
+          <a:prstGeom prst="rect">
+            <a:avLst/>
+          </a:prstGeom>
+          <a:solidFill>
+            <a:srgbClr val="EBEBEF">
+              <a:alpha val="50196"/>
+            </a:srgbClr>
+          </a:solidFill>
+          <a:ln>
+            <a:solidFill>
+              <a:srgbClr val="9B99AF"/>
+            </a:solidFill>
+            <a:prstDash val="dash"/>
+          </a:ln>
+        </p:spPr>
+        <p:style>
+          <a:lnRef idx="2">
+            <a:schemeClr val="accent1">
+              <a:shade val="15000"/>
+            </a:schemeClr>
+          </a:lnRef>
+          <a:fillRef idx="1">
+            <a:schemeClr val="accent1"/>
+          </a:fillRef>
+          <a:effectRef idx="0">
+            <a:schemeClr val="accent1"/>
+          </a:effectRef>
+          <a:fontRef idx="minor">
+            <a:schemeClr val="lt1"/>
+          </a:fontRef>
+        </p:style>
+        <p:txBody>
+          <a:bodyPr rtlCol="0" anchor="ctr"/>
+          <a:lstStyle/>
+          <a:p>
+            <a:pPr algn="ctr"/>
+            <a:r>
+              <a:rPr lang="en-US" sz="800" dirty="0">
+                <a:solidFill>
+                  <a:schemeClr val="tx1"/>
+                </a:solidFill>
+              </a:rPr>
+              <a:t>Undefined </a:t>
+            </a:r>
+          </a:p>
+          <a:p>
+            <a:pPr algn="ctr"/>
+            <a:r>
+              <a:rPr lang="en-US" sz="800" dirty="0">
+                <a:solidFill>
+                  <a:schemeClr val="tx1"/>
+                </a:solidFill>
+              </a:rPr>
+              <a:t>Interaction</a:t>
+            </a:r>
+          </a:p>
+        </p:txBody>
+      </p:sp>
+      <p:grpSp>
+        <p:nvGrpSpPr>
+          <p:cNvPr id="18" name="Group 17">
+            <a:extLst>
+              <a:ext uri="{FF2B5EF4-FFF2-40B4-BE49-F238E27FC236}">
+                <a16:creationId xmlns:a16="http://schemas.microsoft.com/office/drawing/2014/main" id="{D82E2C68-C623-4988-6E85-B58EDDB93358}"/>
+              </a:ext>
+            </a:extLst>
+          </p:cNvPr>
+          <p:cNvGrpSpPr/>
+          <p:nvPr/>
+        </p:nvGrpSpPr>
+        <p:grpSpPr>
+          <a:xfrm>
+            <a:off x="3321745" y="3466949"/>
+            <a:ext cx="2001981" cy="1073298"/>
+            <a:chOff x="2964757" y="3466949"/>
+            <a:chExt cx="2001981" cy="1073298"/>
+          </a:xfrm>
+        </p:grpSpPr>
+        <p:sp>
+          <p:nvSpPr>
+            <p:cNvPr id="14" name="Trapezoid 13">
+              <a:extLst>
+                <a:ext uri="{FF2B5EF4-FFF2-40B4-BE49-F238E27FC236}">
+                  <a16:creationId xmlns:a16="http://schemas.microsoft.com/office/drawing/2014/main" id="{E9E9E321-1793-CAD9-5619-6E2A4E97AD14}"/>
+                </a:ext>
+              </a:extLst>
+            </p:cNvPr>
+            <p:cNvSpPr/>
+            <p:nvPr/>
+          </p:nvSpPr>
+          <p:spPr>
+            <a:xfrm rot="10800000">
+              <a:off x="2964757" y="3466949"/>
+              <a:ext cx="2001981" cy="1073298"/>
+            </a:xfrm>
+            <a:prstGeom prst="trapezoid">
+              <a:avLst>
+                <a:gd name="adj" fmla="val 39326"/>
+              </a:avLst>
+            </a:prstGeom>
+            <a:solidFill>
+              <a:srgbClr val="EBEBEF">
+                <a:alpha val="50196"/>
+              </a:srgbClr>
+            </a:solidFill>
+            <a:ln>
+              <a:solidFill>
+                <a:srgbClr val="9B99AF"/>
+              </a:solidFill>
+              <a:prstDash val="dash"/>
+            </a:ln>
+          </p:spPr>
+          <p:style>
+            <a:lnRef idx="2">
+              <a:schemeClr val="accent1">
+                <a:shade val="15000"/>
+              </a:schemeClr>
+            </a:lnRef>
+            <a:fillRef idx="1">
+              <a:schemeClr val="accent1"/>
+            </a:fillRef>
+            <a:effectRef idx="0">
+              <a:schemeClr val="accent1"/>
+            </a:effectRef>
+            <a:fontRef idx="minor">
+              <a:schemeClr val="lt1"/>
+            </a:fontRef>
+          </p:style>
+          <p:txBody>
+            <a:bodyPr rtlCol="0" anchor="ctr"/>
+            <a:lstStyle/>
+            <a:p>
+              <a:pPr algn="ctr"/>
+              <a:endParaRPr lang="en-US" sz="800" dirty="0">
+                <a:solidFill>
+                  <a:schemeClr val="tx1"/>
+                </a:solidFill>
+              </a:endParaRPr>
+            </a:p>
+          </p:txBody>
+        </p:sp>
+        <p:sp>
+          <p:nvSpPr>
+            <p:cNvPr id="15" name="TextBox 14">
+              <a:extLst>
+                <a:ext uri="{FF2B5EF4-FFF2-40B4-BE49-F238E27FC236}">
+                  <a16:creationId xmlns:a16="http://schemas.microsoft.com/office/drawing/2014/main" id="{C8945C4F-C412-CD9A-49EF-405A3FEC44AD}"/>
+                </a:ext>
+              </a:extLst>
+            </p:cNvPr>
+            <p:cNvSpPr txBox="1"/>
+            <p:nvPr/>
+          </p:nvSpPr>
+          <p:spPr>
+            <a:xfrm>
+              <a:off x="3641780" y="3834321"/>
+              <a:ext cx="647934" cy="338554"/>
+            </a:xfrm>
+            <a:prstGeom prst="rect">
+              <a:avLst/>
+            </a:prstGeom>
+            <a:noFill/>
+          </p:spPr>
+          <p:txBody>
+            <a:bodyPr wrap="none" rtlCol="0">
+              <a:spAutoFit/>
+            </a:bodyPr>
+            <a:lstStyle/>
+            <a:p>
+              <a:r>
+                <a:rPr lang="en-US" sz="800" dirty="0">
+                  <a:solidFill>
+                    <a:schemeClr val="tx1"/>
+                  </a:solidFill>
+                </a:rPr>
+                <a:t>Temporal </a:t>
+              </a:r>
+            </a:p>
+            <a:p>
+              <a:pPr algn="ctr"/>
+              <a:r>
+                <a:rPr lang="en-US" sz="800" dirty="0">
+                  <a:solidFill>
+                    <a:schemeClr val="tx1"/>
+                  </a:solidFill>
+                </a:rPr>
+                <a:t>Coupling</a:t>
+              </a:r>
+            </a:p>
+          </p:txBody>
+        </p:sp>
+      </p:grpSp>
+      <p:sp>
+        <p:nvSpPr>
+          <p:cNvPr id="16" name="Diamond 15">
+            <a:extLst>
+              <a:ext uri="{FF2B5EF4-FFF2-40B4-BE49-F238E27FC236}">
+                <a16:creationId xmlns:a16="http://schemas.microsoft.com/office/drawing/2014/main" id="{936C5848-E554-A7B8-A354-F36D679C71DD}"/>
+              </a:ext>
+            </a:extLst>
+          </p:cNvPr>
+          <p:cNvSpPr/>
+          <p:nvPr/>
+        </p:nvSpPr>
+        <p:spPr>
+          <a:xfrm>
+            <a:off x="6415926" y="3466949"/>
+            <a:ext cx="1408311" cy="1073298"/>
+          </a:xfrm>
+          <a:prstGeom prst="diamond">
+            <a:avLst/>
+          </a:prstGeom>
+          <a:solidFill>
+            <a:srgbClr val="EBEBEF">
+              <a:alpha val="50196"/>
+            </a:srgbClr>
+          </a:solidFill>
+          <a:ln>
+            <a:solidFill>
+              <a:srgbClr val="9B99AF"/>
+            </a:solidFill>
+            <a:prstDash val="dash"/>
+          </a:ln>
+        </p:spPr>
+        <p:style>
+          <a:lnRef idx="2">
+            <a:schemeClr val="accent1">
+              <a:shade val="15000"/>
+            </a:schemeClr>
+          </a:lnRef>
+          <a:fillRef idx="1">
+            <a:schemeClr val="accent1"/>
+          </a:fillRef>
+          <a:effectRef idx="0">
+            <a:schemeClr val="accent1"/>
+          </a:effectRef>
+          <a:fontRef idx="minor">
+            <a:schemeClr val="lt1"/>
+          </a:fontRef>
+        </p:style>
+        <p:txBody>
+          <a:bodyPr rtlCol="0" anchor="ctr"/>
+          <a:lstStyle/>
+          <a:p>
+            <a:pPr algn="ctr"/>
+            <a:r>
+              <a:rPr lang="en-US" sz="800" dirty="0">
+                <a:solidFill>
+                  <a:schemeClr val="tx1"/>
+                </a:solidFill>
+              </a:rPr>
+              <a:t>Handover</a:t>
+            </a:r>
+          </a:p>
+        </p:txBody>
+      </p:sp>
     </p:spTree>
+    <p:extLst>
+      <p:ext uri="{BB962C8B-B14F-4D97-AF65-F5344CB8AC3E}">
+        <p14:creationId xmlns:p14="http://schemas.microsoft.com/office/powerpoint/2010/main" val="1693760494"/>
+      </p:ext>
+    </p:extLst>
   </p:cSld>
   <p:clrMapOvr>
     <a:masterClrMapping/>

</xml_diff>

<commit_message>
Change platform grouping to have a dotted border
</commit_message>
<xml_diff>
--- a/powerpoint/Team Topologies Template for modelling - PowerPoint.pptx
+++ b/powerpoint/Team Topologies Template for modelling - PowerPoint.pptx
@@ -5793,7 +5793,7 @@
             <a:solidFill>
               <a:srgbClr val="6D9EEB"/>
             </a:solidFill>
-            <a:prstDash val="solid"/>
+            <a:prstDash val="sysDot"/>
             <a:round/>
             <a:headEnd type="none" w="sm" len="sm"/>
             <a:tailEnd type="none" w="sm" len="sm"/>
@@ -6176,7 +6176,7 @@
                 <a:cs typeface="Open Sans"/>
                 <a:sym typeface="Open Sans"/>
               </a:rPr>
-              <a:t>Fundamental Topologies</a:t>
+              <a:t>Fundamental Team Types</a:t>
             </a:r>
             <a:endParaRPr sz="1000" dirty="0">
               <a:latin typeface="Open Sans"/>

</xml_diff>

<commit_message>
Update layout and add platform grouping in team types
</commit_message>
<xml_diff>
--- a/powerpoint/Team Topologies Template for modelling - PowerPoint.pptx
+++ b/powerpoint/Team Topologies Template for modelling - PowerPoint.pptx
@@ -5716,8 +5716,8 @@
         </p:nvSpPr>
         <p:spPr>
           <a:xfrm>
-            <a:off x="475612" y="1207711"/>
-            <a:ext cx="2985473" cy="307399"/>
+            <a:off x="616484" y="1369636"/>
+            <a:ext cx="2402941" cy="307399"/>
           </a:xfrm>
           <a:prstGeom prst="roundRect">
             <a:avLst>
@@ -5778,7 +5778,7 @@
         </p:nvSpPr>
         <p:spPr>
           <a:xfrm>
-            <a:off x="3959226" y="1805582"/>
+            <a:off x="3816351" y="1967507"/>
             <a:ext cx="1892309" cy="347968"/>
           </a:xfrm>
           <a:prstGeom prst="roundRect">
@@ -5840,7 +5840,7 @@
         </p:nvSpPr>
         <p:spPr>
           <a:xfrm>
-            <a:off x="1652812" y="1661623"/>
+            <a:off x="1471837" y="1823548"/>
             <a:ext cx="687139" cy="762400"/>
           </a:xfrm>
           <a:prstGeom prst="roundRect">
@@ -5902,7 +5902,7 @@
         </p:nvSpPr>
         <p:spPr>
           <a:xfrm>
-            <a:off x="1415580" y="2586438"/>
+            <a:off x="1234605" y="2748363"/>
             <a:ext cx="1161600" cy="699600"/>
           </a:xfrm>
           <a:prstGeom prst="octagon">
@@ -6078,7 +6078,7 @@
         </p:nvSpPr>
         <p:spPr>
           <a:xfrm>
-            <a:off x="6699342" y="1207711"/>
+            <a:off x="6699342" y="1369636"/>
             <a:ext cx="1403825" cy="515013"/>
           </a:xfrm>
           <a:prstGeom prst="flowChartInputOutput">
@@ -6140,7 +6140,7 @@
         </p:nvSpPr>
         <p:spPr>
           <a:xfrm>
-            <a:off x="857812" y="795605"/>
+            <a:off x="676837" y="871805"/>
             <a:ext cx="2237100" cy="276600"/>
           </a:xfrm>
           <a:prstGeom prst="rect">
@@ -6195,7 +6195,7 @@
         </p:nvSpPr>
         <p:spPr>
           <a:xfrm>
-            <a:off x="3641765" y="790644"/>
+            <a:off x="3498890" y="866844"/>
             <a:ext cx="2433000" cy="276600"/>
           </a:xfrm>
           <a:prstGeom prst="rect">
@@ -6250,7 +6250,7 @@
         </p:nvSpPr>
         <p:spPr>
           <a:xfrm>
-            <a:off x="6939178" y="1849706"/>
+            <a:off x="6939178" y="2125931"/>
             <a:ext cx="915000" cy="804300"/>
           </a:xfrm>
           <a:prstGeom prst="triangle">
@@ -6314,7 +6314,7 @@
         </p:nvSpPr>
         <p:spPr>
           <a:xfrm>
-            <a:off x="6898378" y="2842588"/>
+            <a:off x="6898378" y="3214063"/>
             <a:ext cx="996600" cy="1008000"/>
           </a:xfrm>
           <a:prstGeom prst="ellipse">
@@ -6437,7 +6437,7 @@
         </p:nvSpPr>
         <p:spPr>
           <a:xfrm>
-            <a:off x="969141" y="4086362"/>
+            <a:off x="969141" y="4391162"/>
             <a:ext cx="6971700" cy="576600"/>
           </a:xfrm>
           <a:prstGeom prst="rightArrow">
@@ -6494,7 +6494,7 @@
         </p:nvSpPr>
         <p:spPr>
           <a:xfrm>
-            <a:off x="6265106" y="790644"/>
+            <a:off x="6265106" y="866844"/>
             <a:ext cx="2237100" cy="276600"/>
           </a:xfrm>
           <a:prstGeom prst="rect">
@@ -6555,7 +6555,7 @@
         </p:nvSpPr>
         <p:spPr>
           <a:xfrm>
-            <a:off x="3959225" y="1207711"/>
+            <a:off x="3816350" y="1369636"/>
             <a:ext cx="1892309" cy="347968"/>
           </a:xfrm>
           <a:prstGeom prst="roundRect">
@@ -6599,6 +6599,74 @@
                 <a:sym typeface="Open Sans"/>
               </a:rPr>
               <a:t>Value Stream Grouping</a:t>
+            </a:r>
+            <a:endParaRPr sz="800" dirty="0">
+              <a:latin typeface="Open Sans"/>
+              <a:ea typeface="Open Sans"/>
+              <a:cs typeface="Open Sans"/>
+              <a:sym typeface="Open Sans"/>
+            </a:endParaRPr>
+          </a:p>
+        </p:txBody>
+      </p:sp>
+      <p:sp>
+        <p:nvSpPr>
+          <p:cNvPr id="3" name="Google Shape;55;p13">
+            <a:extLst>
+              <a:ext uri="{FF2B5EF4-FFF2-40B4-BE49-F238E27FC236}">
+                <a16:creationId xmlns:a16="http://schemas.microsoft.com/office/drawing/2014/main" id="{2152A496-9B2E-16A7-6A0A-D217358F18E6}"/>
+              </a:ext>
+            </a:extLst>
+          </p:cNvPr>
+          <p:cNvSpPr/>
+          <p:nvPr/>
+        </p:nvSpPr>
+        <p:spPr>
+          <a:xfrm>
+            <a:off x="676836" y="3749746"/>
+            <a:ext cx="2348495" cy="347968"/>
+          </a:xfrm>
+          <a:prstGeom prst="roundRect">
+            <a:avLst>
+              <a:gd name="adj" fmla="val 0"/>
+            </a:avLst>
+          </a:prstGeom>
+          <a:solidFill>
+            <a:srgbClr val="B7CDF1"/>
+          </a:solidFill>
+          <a:ln w="19050" cap="flat" cmpd="sng">
+            <a:solidFill>
+              <a:srgbClr val="6D9EEB"/>
+            </a:solidFill>
+            <a:prstDash val="solid"/>
+            <a:round/>
+            <a:headEnd type="none" w="sm" len="sm"/>
+            <a:tailEnd type="none" w="sm" len="sm"/>
+          </a:ln>
+        </p:spPr>
+        <p:txBody>
+          <a:bodyPr spcFirstLastPara="1" wrap="square" lIns="91425" tIns="91425" rIns="91425" bIns="91425" anchor="ctr" anchorCtr="0">
+            <a:noAutofit/>
+          </a:bodyPr>
+          <a:lstStyle/>
+          <a:p>
+            <a:pPr marL="0" lvl="0" indent="0" algn="ctr" rtl="0">
+              <a:spcBef>
+                <a:spcPts val="0"/>
+              </a:spcBef>
+              <a:spcAft>
+                <a:spcPts val="0"/>
+              </a:spcAft>
+              <a:buNone/>
+            </a:pPr>
+            <a:r>
+              <a:rPr lang="en-GB" sz="800" dirty="0">
+                <a:latin typeface="Open Sans"/>
+                <a:ea typeface="Open Sans"/>
+                <a:cs typeface="Open Sans"/>
+                <a:sym typeface="Open Sans"/>
+              </a:rPr>
+              <a:t>Platform grouping</a:t>
             </a:r>
             <a:endParaRPr sz="800" dirty="0">
               <a:latin typeface="Open Sans"/>
@@ -6902,7 +6970,7 @@
         </p:nvSpPr>
         <p:spPr>
           <a:xfrm>
-            <a:off x="435036" y="2921397"/>
+            <a:off x="6273861" y="891706"/>
             <a:ext cx="2425927" cy="276600"/>
           </a:xfrm>
           <a:prstGeom prst="rect">
@@ -6963,7 +7031,7 @@
         </p:nvSpPr>
         <p:spPr>
           <a:xfrm>
-            <a:off x="543257" y="1578014"/>
+            <a:off x="476582" y="1578014"/>
             <a:ext cx="2001981" cy="398915"/>
           </a:xfrm>
           <a:prstGeom prst="roundRect">
@@ -7025,8 +7093,8 @@
         </p:nvSpPr>
         <p:spPr>
           <a:xfrm>
-            <a:off x="1066454" y="3466950"/>
-            <a:ext cx="1163089" cy="1073300"/>
+            <a:off x="6933019" y="1345489"/>
+            <a:ext cx="1038918" cy="914531"/>
           </a:xfrm>
           <a:prstGeom prst="rect">
             <a:avLst/>
@@ -7100,8 +7168,8 @@
         </p:nvGrpSpPr>
         <p:grpSpPr>
           <a:xfrm>
-            <a:off x="3321745" y="3466949"/>
-            <a:ext cx="2001981" cy="1073298"/>
+            <a:off x="6658674" y="2704722"/>
+            <a:ext cx="1656299" cy="854286"/>
             <a:chOff x="2964757" y="3466949"/>
             <a:chExt cx="2001981" cy="1073298"/>
           </a:xfrm>
@@ -7183,8 +7251,8 @@
           </p:nvSpPr>
           <p:spPr>
             <a:xfrm>
-              <a:off x="3641780" y="3834321"/>
-              <a:ext cx="647934" cy="338554"/>
+              <a:off x="3574166" y="3834321"/>
+              <a:ext cx="783163" cy="425349"/>
             </a:xfrm>
             <a:prstGeom prst="rect">
               <a:avLst/>
@@ -7197,6 +7265,7 @@
             </a:bodyPr>
             <a:lstStyle/>
             <a:p>
+              <a:pPr algn="ctr"/>
               <a:r>
                 <a:rPr lang="en-US" sz="800" dirty="0">
                   <a:solidFill>
@@ -7234,8 +7303,8 @@
         </p:nvSpPr>
         <p:spPr>
           <a:xfrm>
-            <a:off x="6415926" y="3466949"/>
-            <a:ext cx="1408311" cy="1073298"/>
+            <a:off x="6933019" y="3937035"/>
+            <a:ext cx="1257960" cy="914529"/>
           </a:xfrm>
           <a:prstGeom prst="diamond">
             <a:avLst/>
@@ -7281,6 +7350,129 @@
               </a:rPr>
               <a:t>Handover</a:t>
             </a:r>
+          </a:p>
+        </p:txBody>
+      </p:sp>
+      <p:sp>
+        <p:nvSpPr>
+          <p:cNvPr id="2" name="Rectangle 1">
+            <a:extLst>
+              <a:ext uri="{FF2B5EF4-FFF2-40B4-BE49-F238E27FC236}">
+                <a16:creationId xmlns:a16="http://schemas.microsoft.com/office/drawing/2014/main" id="{A608CDF2-D071-4DA5-4381-71359A9026FF}"/>
+              </a:ext>
+            </a:extLst>
+          </p:cNvPr>
+          <p:cNvSpPr/>
+          <p:nvPr/>
+        </p:nvSpPr>
+        <p:spPr>
+          <a:xfrm>
+            <a:off x="3334082" y="1578013"/>
+            <a:ext cx="2001981" cy="398915"/>
+          </a:xfrm>
+          <a:prstGeom prst="rect">
+            <a:avLst/>
+          </a:prstGeom>
+          <a:solidFill>
+            <a:srgbClr val="EBEBEF"/>
+          </a:solidFill>
+          <a:ln>
+            <a:solidFill>
+              <a:srgbClr val="9B99AF"/>
+            </a:solidFill>
+            <a:prstDash val="sysDot"/>
+          </a:ln>
+        </p:spPr>
+        <p:style>
+          <a:lnRef idx="2">
+            <a:schemeClr val="accent1">
+              <a:shade val="15000"/>
+            </a:schemeClr>
+          </a:lnRef>
+          <a:fillRef idx="1">
+            <a:schemeClr val="accent1"/>
+          </a:fillRef>
+          <a:effectRef idx="0">
+            <a:schemeClr val="accent1"/>
+          </a:effectRef>
+          <a:fontRef idx="minor">
+            <a:schemeClr val="lt1"/>
+          </a:fontRef>
+        </p:style>
+        <p:txBody>
+          <a:bodyPr rtlCol="0" anchor="ctr"/>
+          <a:lstStyle/>
+          <a:p>
+            <a:pPr algn="ctr"/>
+            <a:r>
+              <a:rPr lang="en-US" sz="800" dirty="0">
+                <a:solidFill>
+                  <a:schemeClr val="tx1"/>
+                </a:solidFill>
+              </a:rPr>
+              <a:t>Undefined Grouping</a:t>
+            </a:r>
+          </a:p>
+        </p:txBody>
+      </p:sp>
+      <p:sp>
+        <p:nvSpPr>
+          <p:cNvPr id="3" name="Google Shape;60;p13">
+            <a:extLst>
+              <a:ext uri="{FF2B5EF4-FFF2-40B4-BE49-F238E27FC236}">
+                <a16:creationId xmlns:a16="http://schemas.microsoft.com/office/drawing/2014/main" id="{1BDB6BD8-CF12-2AA5-E925-1534E74550F8}"/>
+              </a:ext>
+            </a:extLst>
+          </p:cNvPr>
+          <p:cNvSpPr txBox="1"/>
+          <p:nvPr/>
+        </p:nvSpPr>
+        <p:spPr>
+          <a:xfrm>
+            <a:off x="3204185" y="891706"/>
+            <a:ext cx="2237100" cy="276600"/>
+          </a:xfrm>
+          <a:prstGeom prst="rect">
+            <a:avLst/>
+          </a:prstGeom>
+          <a:noFill/>
+          <a:ln>
+            <a:noFill/>
+          </a:ln>
+        </p:spPr>
+        <p:txBody>
+          <a:bodyPr spcFirstLastPara="1" wrap="square" lIns="91425" tIns="91425" rIns="91425" bIns="91425" anchor="t" anchorCtr="0">
+            <a:noAutofit/>
+          </a:bodyPr>
+          <a:lstStyle/>
+          <a:p>
+            <a:pPr marL="0" lvl="0" indent="0" algn="ctr" rtl="0">
+              <a:spcBef>
+                <a:spcPts val="0"/>
+              </a:spcBef>
+              <a:spcAft>
+                <a:spcPts val="0"/>
+              </a:spcAft>
+              <a:buNone/>
+            </a:pPr>
+            <a:r>
+              <a:rPr lang="en-GB" sz="1000" b="1" u="sng" dirty="0">
+                <a:solidFill>
+                  <a:srgbClr val="1A1A1A"/>
+                </a:solidFill>
+                <a:latin typeface="Open Sans"/>
+                <a:ea typeface="Open Sans"/>
+                <a:cs typeface="Open Sans"/>
+                <a:sym typeface="Open Sans"/>
+              </a:rPr>
+              <a:t>Supplementary Groupings</a:t>
+            </a:r>
+            <a:endParaRPr sz="1000" dirty="0">
+              <a:latin typeface="Open Sans"/>
+              <a:ea typeface="Open Sans"/>
+              <a:cs typeface="Open Sans"/>
+              <a:sym typeface="Open Sans"/>
+            </a:endParaRPr>
           </a:p>
         </p:txBody>
       </p:sp>

</xml_diff>